<commit_message>
Rajasthan: names left off by district and constituency, from the District Election Officers' figures as the press printed them
22 of 41 districts and 110 of 199 constituencies (27.8 lakh of 41.8 lakh names),
from Dainik Bhaskar and Amar Ujala of 16 and 17 December 2025. Each printed
table is held to its own sums, with the printed slips pinned so a new one fails
the build. Shown as press on the overview, the FAQ and the seat pages, never
added to the CEO's figures. They rank places much as the change in the roll
does (0.85 across constituencies), Sirohi gives the one split by sex (women
55.7% of the names left off against 48.3% of the roll), and the tables are in
the downloads with every source address.

Co-Authored-By: Claude Opus 5.5 <noreply@anthropic.com>
Claude-Session: https://claude.ai/code/session_012JjD5mhtvLxzAXoZHMZYE5
</commit_message>
<xml_diff>
--- a/reports/rajasthan-sir-2026-deck.pptx
+++ b/reports/rajasthan-sir-2026-deck.pptx
@@ -12,9 +12,10 @@
     <p:sldId id="260" r:id="rId6"/>
     <p:sldId id="261" r:id="rId7"/>
     <p:sldId id="262" r:id="rId8"/>
+    <p:sldId id="263" r:id="rId9"/>
   </p:sldIdLst>
   <p:notesMasterIdLst>
-    <p:notesMasterId r:id="rId9"/>
+    <p:notesMasterId r:id="rId10"/>
   </p:notesMasterIdLst>
   <p:sldSz cx="12192000" cy="6858000"/>
   <p:notesSz cx="6858000" cy="12192000"/>
@@ -772,7 +773,7 @@
           <a:p>
             <a:r>
               <a:rPr lang="en-US" dirty="0"/>
-              <a:t>From the 2023 election to the final roll, the roll of general electors fell by 10.6 lakh, 2.0 per 100. It fell most in Salumber (5.7 per 100), Jodhpur and Udaipur, and grew in 6 districts, Balotara, Deeg, Dholpur, Jaisalmer, Phalodi and Barmer. Across the 200 constituencies it runs from a rise of 5.3 per 100 in Gudamalani to a fall of 17.4 in Jodhpur, and 49 constituencies grew. The change takes in more than two years of new voters, deaths and moves as well as the revision.</a:t>
+              <a:t>In the 22 districts the press printed, 27.8 lakh names were left off, 66.4% of the state's 41.8 lakh. Jodhpur lost the most, 11.2 of every 100 on its roll, then Jaipur (11.1) and Kota (10.4). Barmer lost the fewest, 4.0. The line marks the state's 7.7. In the 20 districts that gave the five reasons, 59.6% of the names were entered as shifted for good, 21.3% as dead, 11.4% as absent and 7.1% as enrolled at more than one place. A reason is what the officer wrote down, and nobody checked it.</a:t>
             </a:r>
             <a:endParaRPr lang="en-US" dirty="0"/>
           </a:p>
@@ -860,7 +861,7 @@
           <a:p>
             <a:r>
               <a:rPr lang="en-US" dirty="0"/>
-              <a:t>Women were 47.7% of the final roll, against 48.0% of the 2023 roll, and their share fell in 165 of the 200 constituencies. Of the names deleted after the draft, women were 55.4%, and of those added 51.3%. No split by sex of the names left off the draft has been published.</a:t>
+              <a:t>From the 2023 election to the final roll, the roll of general electors fell by 10.6 lakh, 2.0 per 100. It fell most in Salumber (5.7 per 100), Jodhpur and Udaipur, and grew in 6 districts, Balotara, Deeg, Dholpur, Jaisalmer, Phalodi and Barmer. Across the 200 constituencies it runs from a rise of 5.3 per 100 in Gudamalani to a fall of 17.4 in Jodhpur, and 49 constituencies grew. The change takes in more than two years of new voters, deaths and moves as well as the revision.</a:t>
             </a:r>
             <a:endParaRPr lang="en-US" dirty="0"/>
           </a:p>
@@ -948,7 +949,7 @@
           <a:p>
             <a:r>
               <a:rPr lang="en-US" dirty="0"/>
-              <a:t>In 32 of the 200 constituencies the roll fell by more than the 2023 winning margin. Not everyone on a roll votes, so scaled down by each seat's 2023 turnout it is 27. The roll fell by 2.3 per 100 in the BJP's 115 seats and 1.5 in the Congress's 70. Against their own districts the two are within half a point of zero (0.1 and -0.3). So most of the difference comes from where each party's seats are. Orange dots are BJP seats, green Congress and purple the rest.</a:t>
+              <a:t>Women were 47.7% of the final roll, against 48.0% of the 2023 roll, and their share fell in 165 of the 200 constituencies. Of the names deleted after the draft, women were 55.4%, and of those added 51.3%. No split by sex of the names left off has been published for the state. One district gave one: in Sirohi, by the District Election Officer's figures as Amar Ujala printed them, women were 55.7% of the 85,596 names left off, against 48.3% of the roll before the revision.</a:t>
             </a:r>
             <a:endParaRPr lang="en-US" dirty="0"/>
           </a:p>
@@ -1036,7 +1037,7 @@
           <a:p>
             <a:r>
               <a:rPr lang="en-US" dirty="0"/>
-              <a:t/>
+              <a:t>In 32 of the 200 constituencies the roll fell by more than the 2023 winning margin. Not everyone on a roll votes, so scaled down by each seat's 2023 turnout it is 27. The roll fell by 2.3 per 100 in the BJP's 115 seats and 1.5 in the Congress's 70. Against their own districts the two are within half a point of zero (0.1 and -0.3). So most of the difference comes from where each party's seats are. Orange dots are BJP seats, green Congress and purple the rest.</a:t>
             </a:r>
             <a:endParaRPr lang="en-US" dirty="0"/>
           </a:p>
@@ -1060,6 +1061,94 @@
             <a:fld id="{F7021451-1387-4CA6-816F-3879F97B5CBC}" type="slidenum">
               <a:rPr lang="en-US"/>
               <a:t>7</a:t>
+            </a:fld>
+            <a:endParaRPr lang="en-US"/>
+          </a:p>
+        </p:txBody>
+      </p:sp>
+    </p:spTree>
+    <p:extLst>
+      <p:ext uri="{BB962C8B-B14F-4D97-AF65-F5344CB8AC3E}">
+        <p14:creationId xmlns:p14="http://schemas.microsoft.com/office/powerpoint/2010/main" val="1024086991"/>
+      </p:ext>
+    </p:extLst>
+  </p:cSld>
+  <p:clrMapOvr>
+    <a:masterClrMapping/>
+  </p:clrMapOvr>
+</p:notes>
+</file>
+
+<file path=ppt/notesSlides/notesSlide8.xml><?xml version="1.0" encoding="utf-8"?>
+<p:notes xmlns:a="http://schemas.openxmlformats.org/drawingml/2006/main" xmlns:r="http://schemas.openxmlformats.org/officeDocument/2006/relationships" xmlns:p="http://schemas.openxmlformats.org/presentationml/2006/main">
+  <p:cSld>
+    <p:spTree>
+      <p:nvGrpSpPr>
+        <p:cNvPr id="1" name=""/>
+        <p:cNvGrpSpPr/>
+        <p:nvPr/>
+      </p:nvGrpSpPr>
+      <p:grpSpPr>
+        <a:xfrm>
+          <a:off x="0" y="0"/>
+          <a:ext cx="0" cy="0"/>
+          <a:chOff x="0" y="0"/>
+          <a:chExt cx="0" cy="0"/>
+        </a:xfrm>
+      </p:grpSpPr>
+      <p:sp>
+        <p:nvSpPr>
+          <p:cNvPr id="2" name="Slide Image Placeholder 1"/>
+          <p:cNvSpPr>
+            <a:spLocks noGrp="1" noRot="1" noChangeAspect="1"/>
+          </p:cNvSpPr>
+          <p:nvPr>
+            <p:ph type="sldImg"/>
+          </p:nvPr>
+        </p:nvSpPr>
+        <p:spPr/>
+      </p:sp>
+      <p:sp>
+        <p:nvSpPr>
+          <p:cNvPr id="3" name="Notes Placeholder 2"/>
+          <p:cNvSpPr>
+            <a:spLocks noGrp="1"/>
+          </p:cNvSpPr>
+          <p:nvPr>
+            <p:ph type="body" idx="1"/>
+          </p:nvPr>
+        </p:nvSpPr>
+        <p:spPr/>
+        <p:txBody>
+          <a:bodyPr/>
+          <a:lstStyle/>
+          <a:p>
+            <a:r>
+              <a:rPr lang="en-US" dirty="0"/>
+              <a:t/>
+            </a:r>
+            <a:endParaRPr lang="en-US" dirty="0"/>
+          </a:p>
+        </p:txBody>
+      </p:sp>
+      <p:sp>
+        <p:nvSpPr>
+          <p:cNvPr id="4" name="Slide Number Placeholder 3"/>
+          <p:cNvSpPr>
+            <a:spLocks noGrp="1"/>
+          </p:cNvSpPr>
+          <p:nvPr>
+            <p:ph type="sldNum" sz="quarter" idx="10"/>
+          </p:nvPr>
+        </p:nvSpPr>
+        <p:spPr/>
+        <p:txBody>
+          <a:bodyPr/>
+          <a:lstStyle/>
+          <a:p>
+            <a:fld id="{F7021451-1387-4CA6-816F-3879F97B5CBC}" type="slidenum">
+              <a:rPr lang="en-US"/>
+              <a:t>8</a:t>
             </a:fld>
             <a:endParaRPr lang="en-US"/>
           </a:p>
@@ -1556,7 +1645,7 @@
               <a:buAutoNum type="arabicPeriod" startAt="1"/>
             </a:pPr>
             <a:r>
-              <a:rPr lang="en-US" sz="1500" dirty="0">
+              <a:rPr lang="en-US" sz="1300" dirty="0">
                 <a:solidFill>
                   <a:srgbClr val="16130F"/>
                 </a:solidFill>
@@ -1566,7 +1655,7 @@
               </a:rPr>
               <a:t>Rajasthan's draft roll left off 41.8 lakh names, 7.7 of every 100 electors on the roll before the revision.</a:t>
             </a:r>
-            <a:endParaRPr lang="en-US" sz="1500" dirty="0"/>
+            <a:endParaRPr lang="en-US" sz="1300" dirty="0"/>
           </a:p>
           <a:p>
             <a:pPr marL="342900" indent="-342900">
@@ -1578,7 +1667,7 @@
               <a:buAutoNum type="arabicPeriod" startAt="1"/>
             </a:pPr>
             <a:r>
-              <a:rPr lang="en-US" sz="1500" dirty="0">
+              <a:rPr lang="en-US" sz="1300" dirty="0">
                 <a:solidFill>
                   <a:srgbClr val="16130F"/>
                 </a:solidFill>
@@ -1588,7 +1677,7 @@
               </a:rPr>
               <a:t>After the draft 12.9 lakh were added and 2.4 lakh more deleted, so 44.3 lakh had been removed by the time of the final roll. The final roll was 10.5 lakh larger than the draft, which is at most 25.1% of what was left off.</a:t>
             </a:r>
-            <a:endParaRPr lang="en-US" sz="1500" dirty="0"/>
+            <a:endParaRPr lang="en-US" sz="1300" dirty="0"/>
           </a:p>
           <a:p>
             <a:pPr marL="342900" indent="-342900">
@@ -1600,7 +1689,29 @@
               <a:buAutoNum type="arabicPeriod" startAt="1"/>
             </a:pPr>
             <a:r>
-              <a:rPr lang="en-US" sz="1500" dirty="0">
+              <a:rPr lang="en-US" sz="1300" dirty="0">
+                <a:solidFill>
+                  <a:srgbClr val="16130F"/>
+                </a:solidFill>
+                <a:latin typeface="Calibri" pitchFamily="34" charset="0"/>
+                <a:ea typeface="Calibri" pitchFamily="34" charset="-122"/>
+                <a:cs typeface="Calibri" pitchFamily="34" charset="-120"/>
+              </a:rPr>
+              <a:t>The District Election Officers' own figures, as two newspapers printed them for 22 districts, put Jodhpur highest, with 11.2 of every 100 names left off the draft, and Barmer lowest, with 4.0.</a:t>
+            </a:r>
+            <a:endParaRPr lang="en-US" sz="1300" dirty="0"/>
+          </a:p>
+          <a:p>
+            <a:pPr marL="342900" indent="-342900">
+              <a:spcAft>
+                <a:spcPts val="800"/>
+              </a:spcAft>
+              <a:buSzPct val="100000"/>
+              <a:buFont typeface="+mj-lt"/>
+              <a:buAutoNum type="arabicPeriod" startAt="1"/>
+            </a:pPr>
+            <a:r>
+              <a:rPr lang="en-US" sz="1300" dirty="0">
                 <a:solidFill>
                   <a:srgbClr val="16130F"/>
                 </a:solidFill>
@@ -1610,7 +1721,7 @@
               </a:rPr>
               <a:t>From the 2023 election to the final roll, the roll fell most in Salumber (5.7 per 100) and grew in Balotara, Deeg, Dholpur, Jaisalmer, Phalodi and Barmer.</a:t>
             </a:r>
-            <a:endParaRPr lang="en-US" sz="1500" dirty="0"/>
+            <a:endParaRPr lang="en-US" sz="1300" dirty="0"/>
           </a:p>
           <a:p>
             <a:pPr marL="342900" indent="-342900">
@@ -1622,7 +1733,7 @@
               <a:buAutoNum type="arabicPeriod" startAt="1"/>
             </a:pPr>
             <a:r>
-              <a:rPr lang="en-US" sz="1500" dirty="0">
+              <a:rPr lang="en-US" sz="1300" dirty="0">
                 <a:solidFill>
                   <a:srgbClr val="16130F"/>
                 </a:solidFill>
@@ -1632,7 +1743,7 @@
               </a:rPr>
               <a:t>Women's share of the roll fell in 165 of 200 constituencies, from 48.0% in 2023 to 47.7%, and women were 55.4% of the names deleted after the draft.</a:t>
             </a:r>
-            <a:endParaRPr lang="en-US" sz="1500" dirty="0"/>
+            <a:endParaRPr lang="en-US" sz="1300" dirty="0"/>
           </a:p>
           <a:p>
             <a:pPr marL="342900" indent="-342900">
@@ -1644,7 +1755,7 @@
               <a:buAutoNum type="arabicPeriod" startAt="1"/>
             </a:pPr>
             <a:r>
-              <a:rPr lang="en-US" sz="1500" dirty="0">
+              <a:rPr lang="en-US" sz="1300" dirty="0">
                 <a:solidFill>
                   <a:srgbClr val="16130F"/>
                 </a:solidFill>
@@ -1654,7 +1765,7 @@
               </a:rPr>
               <a:t>In 32 of the 200 constituencies the roll fell by more than the 2023 winning margin.</a:t>
             </a:r>
-            <a:endParaRPr lang="en-US" sz="1500" dirty="0"/>
+            <a:endParaRPr lang="en-US" sz="1300" dirty="0"/>
           </a:p>
         </p:txBody>
       </p:sp>
@@ -1770,7 +1881,7 @@
       </p:sp>
       <p:pic>
         <p:nvPicPr>
-          <p:cNvPr id="4" name="Image 0" descr="/tmp/pack-8Tsy5x/rj-rajasthan-1.png">    </p:cNvPr>
+          <p:cNvPr id="4" name="Image 0" descr="/tmp/pack-psk9qz/rj-rajasthan-1.png">    </p:cNvPr>
           <p:cNvPicPr>
             <a:picLocks noChangeAspect="1"/>
           </p:cNvPicPr>
@@ -1943,7 +2054,7 @@
       </p:sp>
       <p:pic>
         <p:nvPicPr>
-          <p:cNvPr id="4" name="Image 0" descr="/tmp/pack-8Tsy5x/rj-rajasthan-2.png">    </p:cNvPr>
+          <p:cNvPr id="4" name="Image 0" descr="/tmp/pack-psk9qz/rj-rajasthan-2.png">    </p:cNvPr>
           <p:cNvPicPr>
             <a:picLocks noChangeAspect="1"/>
           </p:cNvPicPr>
@@ -2069,7 +2180,7 @@
                 <a:ea typeface="Calibri" pitchFamily="34" charset="-122"/>
                 <a:cs typeface="Calibri" pitchFamily="34" charset="-120"/>
               </a:rPr>
-              <a:t>RAJASTHAN 2026  ·  Per 100 electors, by district</a:t>
+              <a:t>RAJASTHAN 2026  ·  Names left off, district by district, as the press printed them</a:t>
             </a:r>
             <a:endParaRPr lang="en-US" sz="1000" dirty="0"/>
           </a:p>
@@ -2108,7 +2219,7 @@
                 <a:ea typeface="Cambria" pitchFamily="34" charset="-122"/>
                 <a:cs typeface="Cambria" pitchFamily="34" charset="-120"/>
               </a:rPr>
-              <a:t>From the 2023 election to the final roll, the roll of general electors fell by 10.6 lakh, 2.0 per 100.</a:t>
+              <a:t>In the 22 districts the press printed, 27.8 lakh names were left off, 66.4% of the state's 41.8 lakh.</a:t>
             </a:r>
             <a:endParaRPr lang="en-US" sz="1900" dirty="0"/>
           </a:p>
@@ -2116,7 +2227,7 @@
       </p:sp>
       <p:pic>
         <p:nvPicPr>
-          <p:cNvPr id="4" name="Image 0" descr="/tmp/pack-8Tsy5x/rj-rajasthan-3.png">    </p:cNvPr>
+          <p:cNvPr id="4" name="Image 0" descr="/tmp/pack-psk9qz/rj-rajasthan-3.png">    </p:cNvPr>
           <p:cNvPicPr>
             <a:picLocks noChangeAspect="1"/>
           </p:cNvPicPr>
@@ -2130,8 +2241,8 @@
         </p:blipFill>
         <p:spPr>
           <a:xfrm>
-            <a:off x="9852144" y="1691640"/>
-            <a:ext cx="1790912" cy="4709160"/>
+            <a:off x="2950946" y="1691640"/>
+            <a:ext cx="6289802" cy="4617720"/>
           </a:xfrm>
           <a:prstGeom prst="rect">
             <a:avLst/>
@@ -2141,45 +2252,6 @@
       <p:sp>
         <p:nvSpPr>
           <p:cNvPr id="5" name="Text 2"/>
-          <p:cNvSpPr/>
-          <p:nvPr/>
-        </p:nvSpPr>
-        <p:spPr>
-          <a:xfrm>
-            <a:off x="548640" y="1691640"/>
-            <a:ext cx="8937744" cy="4709160"/>
-          </a:xfrm>
-          <a:prstGeom prst="rect">
-            <a:avLst/>
-          </a:prstGeom>
-          <a:noFill/>
-          <a:ln/>
-        </p:spPr>
-        <p:txBody>
-          <a:bodyPr wrap="square" rtlCol="0" anchor="t"/>
-          <a:lstStyle/>
-          <a:p>
-            <a:pPr indent="0" marL="0">
-              <a:buNone/>
-            </a:pPr>
-            <a:r>
-              <a:rPr lang="en-US" sz="1300" dirty="0">
-                <a:solidFill>
-                  <a:srgbClr val="16130F"/>
-                </a:solidFill>
-                <a:latin typeface="Calibri" pitchFamily="34" charset="0"/>
-                <a:ea typeface="Calibri" pitchFamily="34" charset="-122"/>
-                <a:cs typeface="Calibri" pitchFamily="34" charset="-120"/>
-              </a:rPr>
-              <a:t>It fell most in Salumber (5.7 per 100), Jodhpur and Udaipur, and grew in 6 districts, Balotara, Deeg, Dholpur, Jaisalmer, Phalodi and Barmer. Across the 200 constituencies it runs from a rise of 5.3 per 100 in Gudamalani to a fall of 17.4 in Jodhpur, and 49 constituencies grew. The change takes in more than two years of new voters, deaths and moves as well as the revision.</a:t>
-            </a:r>
-            <a:endParaRPr lang="en-US" sz="1300" dirty="0"/>
-          </a:p>
-        </p:txBody>
-      </p:sp>
-      <p:sp>
-        <p:nvSpPr>
-          <p:cNvPr id="6" name="Text 3"/>
           <p:cNvSpPr/>
           <p:nvPr/>
         </p:nvSpPr>
@@ -2281,7 +2353,7 @@
                 <a:ea typeface="Calibri" pitchFamily="34" charset="-122"/>
                 <a:cs typeface="Calibri" pitchFamily="34" charset="-120"/>
               </a:rPr>
-              <a:t>RAJASTHAN 2026  ·  Women</a:t>
+              <a:t>RAJASTHAN 2026  ·  Per 100 electors, by district</a:t>
             </a:r>
             <a:endParaRPr lang="en-US" sz="1000" dirty="0"/>
           </a:p>
@@ -2320,7 +2392,7 @@
                 <a:ea typeface="Cambria" pitchFamily="34" charset="-122"/>
                 <a:cs typeface="Cambria" pitchFamily="34" charset="-120"/>
               </a:rPr>
-              <a:t>Women were 47.7% of the final roll, against 48.0% of the 2023 roll, and their share fell in 165 of the 200 constituencies.</a:t>
+              <a:t>From the 2023 election to the final roll, the roll of general electors fell by 10.6 lakh, 2.0 per 100.</a:t>
             </a:r>
             <a:endParaRPr lang="en-US" sz="1900" dirty="0"/>
           </a:p>
@@ -2328,7 +2400,7 @@
       </p:sp>
       <p:pic>
         <p:nvPicPr>
-          <p:cNvPr id="4" name="Image 0" descr="/tmp/pack-8Tsy5x/rj-rajasthan-4.png">    </p:cNvPr>
+          <p:cNvPr id="4" name="Image 0" descr="/tmp/pack-psk9qz/rj-rajasthan-4.png">    </p:cNvPr>
           <p:cNvPicPr>
             <a:picLocks noChangeAspect="1"/>
           </p:cNvPicPr>
@@ -2342,8 +2414,8 @@
         </p:blipFill>
         <p:spPr>
           <a:xfrm>
-            <a:off x="2294867" y="1691640"/>
-            <a:ext cx="7601961" cy="4617720"/>
+            <a:off x="9852144" y="1691640"/>
+            <a:ext cx="1790912" cy="4709160"/>
           </a:xfrm>
           <a:prstGeom prst="rect">
             <a:avLst/>
@@ -2353,6 +2425,45 @@
       <p:sp>
         <p:nvSpPr>
           <p:cNvPr id="5" name="Text 2"/>
+          <p:cNvSpPr/>
+          <p:nvPr/>
+        </p:nvSpPr>
+        <p:spPr>
+          <a:xfrm>
+            <a:off x="548640" y="1691640"/>
+            <a:ext cx="8937744" cy="4709160"/>
+          </a:xfrm>
+          <a:prstGeom prst="rect">
+            <a:avLst/>
+          </a:prstGeom>
+          <a:noFill/>
+          <a:ln/>
+        </p:spPr>
+        <p:txBody>
+          <a:bodyPr wrap="square" rtlCol="0" anchor="t"/>
+          <a:lstStyle/>
+          <a:p>
+            <a:pPr indent="0" marL="0">
+              <a:buNone/>
+            </a:pPr>
+            <a:r>
+              <a:rPr lang="en-US" sz="1300" dirty="0">
+                <a:solidFill>
+                  <a:srgbClr val="16130F"/>
+                </a:solidFill>
+                <a:latin typeface="Calibri" pitchFamily="34" charset="0"/>
+                <a:ea typeface="Calibri" pitchFamily="34" charset="-122"/>
+                <a:cs typeface="Calibri" pitchFamily="34" charset="-120"/>
+              </a:rPr>
+              <a:t>It fell most in Salumber (5.7 per 100), Jodhpur and Udaipur, and grew in 6 districts, Balotara, Deeg, Dholpur, Jaisalmer, Phalodi and Barmer. Across the 200 constituencies it runs from a rise of 5.3 per 100 in Gudamalani to a fall of 17.4 in Jodhpur, and 49 constituencies grew. The change takes in more than two years of new voters, deaths and moves as well as the revision.</a:t>
+            </a:r>
+            <a:endParaRPr lang="en-US" sz="1300" dirty="0"/>
+          </a:p>
+        </p:txBody>
+      </p:sp>
+      <p:sp>
+        <p:nvSpPr>
+          <p:cNvPr id="6" name="Text 3"/>
           <p:cNvSpPr/>
           <p:nvPr/>
         </p:nvSpPr>
@@ -2454,7 +2565,7 @@
                 <a:ea typeface="Calibri" pitchFamily="34" charset="-122"/>
                 <a:cs typeface="Calibri" pitchFamily="34" charset="-120"/>
               </a:rPr>
-              <a:t>RAJASTHAN 2026  ·  Against the 2023 margins</a:t>
+              <a:t>RAJASTHAN 2026  ·  Women</a:t>
             </a:r>
             <a:endParaRPr lang="en-US" sz="1000" dirty="0"/>
           </a:p>
@@ -2485,7 +2596,7 @@
               <a:buNone/>
             </a:pPr>
             <a:r>
-              <a:rPr lang="en-US" sz="2200" b="1" dirty="0">
+              <a:rPr lang="en-US" sz="1900" b="1" dirty="0">
                 <a:solidFill>
                   <a:srgbClr val="16130F"/>
                 </a:solidFill>
@@ -2493,15 +2604,15 @@
                 <a:ea typeface="Cambria" pitchFamily="34" charset="-122"/>
                 <a:cs typeface="Cambria" pitchFamily="34" charset="-120"/>
               </a:rPr>
-              <a:t>In 32 of the 200 constituencies the roll fell by more than the 2023 winning margin.</a:t>
-            </a:r>
-            <a:endParaRPr lang="en-US" sz="2200" dirty="0"/>
+              <a:t>Women were 47.7% of the final roll, against 48.0% of the 2023 roll, and their share fell in 165 of the 200 constituencies.</a:t>
+            </a:r>
+            <a:endParaRPr lang="en-US" sz="1900" dirty="0"/>
           </a:p>
         </p:txBody>
       </p:sp>
       <p:pic>
         <p:nvPicPr>
-          <p:cNvPr id="4" name="Image 0" descr="/tmp/pack-8Tsy5x/rj-rajasthan-5.png">    </p:cNvPr>
+          <p:cNvPr id="4" name="Image 0" descr="/tmp/pack-psk9qz/rj-rajasthan-5.png">    </p:cNvPr>
           <p:cNvPicPr>
             <a:picLocks noChangeAspect="1"/>
           </p:cNvPicPr>
@@ -2573,6 +2684,179 @@
 <file path=ppt/slides/slide7.xml><?xml version="1.0" encoding="utf-8"?>
 <p:sld xmlns:a="http://schemas.openxmlformats.org/drawingml/2006/main" xmlns:r="http://schemas.openxmlformats.org/officeDocument/2006/relationships" xmlns:p="http://schemas.openxmlformats.org/presentationml/2006/main">
   <p:cSld name="Slide 7">
+    <p:bg>
+      <p:bgPr>
+        <a:solidFill>
+          <a:srgbClr val="FFFFFF"/>
+        </a:solidFill>
+      </p:bgPr>
+    </p:bg>
+    <p:spTree>
+      <p:nvGrpSpPr>
+        <p:cNvPr id="1" name=""/>
+        <p:cNvGrpSpPr/>
+        <p:nvPr/>
+      </p:nvGrpSpPr>
+      <p:grpSpPr>
+        <a:xfrm>
+          <a:off x="0" y="0"/>
+          <a:ext cx="0" cy="0"/>
+          <a:chOff x="0" y="0"/>
+          <a:chExt cx="0" cy="0"/>
+        </a:xfrm>
+      </p:grpSpPr>
+      <p:sp>
+        <p:nvSpPr>
+          <p:cNvPr id="2" name="Text 0"/>
+          <p:cNvSpPr/>
+          <p:nvPr/>
+        </p:nvSpPr>
+        <p:spPr>
+          <a:xfrm>
+            <a:off x="548640" y="274320"/>
+            <a:ext cx="11094415" cy="274320"/>
+          </a:xfrm>
+          <a:prstGeom prst="rect">
+            <a:avLst/>
+          </a:prstGeom>
+          <a:noFill/>
+          <a:ln/>
+        </p:spPr>
+        <p:txBody>
+          <a:bodyPr wrap="square" rtlCol="0" anchor="ctr"/>
+          <a:lstStyle/>
+          <a:p>
+            <a:pPr indent="0" marL="0">
+              <a:buNone/>
+            </a:pPr>
+            <a:r>
+              <a:rPr lang="en-US" sz="1000" b="1" dirty="0">
+                <a:solidFill>
+                  <a:srgbClr val="B3261E"/>
+                </a:solidFill>
+                <a:latin typeface="Calibri" pitchFamily="34" charset="0"/>
+                <a:ea typeface="Calibri" pitchFamily="34" charset="-122"/>
+                <a:cs typeface="Calibri" pitchFamily="34" charset="-120"/>
+              </a:rPr>
+              <a:t>RAJASTHAN 2026  ·  Against the 2023 margins</a:t>
+            </a:r>
+            <a:endParaRPr lang="en-US" sz="1000" dirty="0"/>
+          </a:p>
+        </p:txBody>
+      </p:sp>
+      <p:sp>
+        <p:nvSpPr>
+          <p:cNvPr id="3" name="Text 1"/>
+          <p:cNvSpPr/>
+          <p:nvPr/>
+        </p:nvSpPr>
+        <p:spPr>
+          <a:xfrm>
+            <a:off x="548640" y="548640"/>
+            <a:ext cx="11094415" cy="1051560"/>
+          </a:xfrm>
+          <a:prstGeom prst="rect">
+            <a:avLst/>
+          </a:prstGeom>
+          <a:noFill/>
+          <a:ln/>
+        </p:spPr>
+        <p:txBody>
+          <a:bodyPr wrap="square" rtlCol="0" anchor="t"/>
+          <a:lstStyle/>
+          <a:p>
+            <a:pPr indent="0" marL="0">
+              <a:buNone/>
+            </a:pPr>
+            <a:r>
+              <a:rPr lang="en-US" sz="2200" b="1" dirty="0">
+                <a:solidFill>
+                  <a:srgbClr val="16130F"/>
+                </a:solidFill>
+                <a:latin typeface="Cambria" pitchFamily="34" charset="0"/>
+                <a:ea typeface="Cambria" pitchFamily="34" charset="-122"/>
+                <a:cs typeface="Cambria" pitchFamily="34" charset="-120"/>
+              </a:rPr>
+              <a:t>In 32 of the 200 constituencies the roll fell by more than the 2023 winning margin.</a:t>
+            </a:r>
+            <a:endParaRPr lang="en-US" sz="2200" dirty="0"/>
+          </a:p>
+        </p:txBody>
+      </p:sp>
+      <p:pic>
+        <p:nvPicPr>
+          <p:cNvPr id="4" name="Image 0" descr="/tmp/pack-psk9qz/rj-rajasthan-6.png">    </p:cNvPr>
+          <p:cNvPicPr>
+            <a:picLocks noChangeAspect="1"/>
+          </p:cNvPicPr>
+          <p:nvPr/>
+        </p:nvPicPr>
+        <p:blipFill>
+          <a:blip r:embed="rId1"/>
+          <a:stretch>
+            <a:fillRect/>
+          </a:stretch>
+        </p:blipFill>
+        <p:spPr>
+          <a:xfrm>
+            <a:off x="2294867" y="1691640"/>
+            <a:ext cx="7601961" cy="4617720"/>
+          </a:xfrm>
+          <a:prstGeom prst="rect">
+            <a:avLst/>
+          </a:prstGeom>
+        </p:spPr>
+      </p:pic>
+      <p:sp>
+        <p:nvSpPr>
+          <p:cNvPr id="5" name="Text 2"/>
+          <p:cNvSpPr/>
+          <p:nvPr/>
+        </p:nvSpPr>
+        <p:spPr>
+          <a:xfrm>
+            <a:off x="548640" y="6446520"/>
+            <a:ext cx="11094415" cy="274320"/>
+          </a:xfrm>
+          <a:prstGeom prst="rect">
+            <a:avLst/>
+          </a:prstGeom>
+          <a:noFill/>
+          <a:ln/>
+        </p:spPr>
+        <p:txBody>
+          <a:bodyPr wrap="square" rtlCol="0" anchor="ctr"/>
+          <a:lstStyle/>
+          <a:p>
+            <a:pPr indent="0" marL="0">
+              <a:buNone/>
+            </a:pPr>
+            <a:r>
+              <a:rPr lang="en-US" sz="900" dirty="0">
+                <a:solidFill>
+                  <a:srgbClr val="5A534A"/>
+                </a:solidFill>
+                <a:latin typeface="Calibri" pitchFamily="34" charset="0"/>
+                <a:ea typeface="Calibri" pitchFamily="34" charset="-122"/>
+                <a:cs typeface="Calibri" pitchFamily="34" charset="-120"/>
+              </a:rPr>
+              <a:t>Figures as published by the Chief Electoral Officer or the Election Commission; the method section of the report gives each source.</a:t>
+            </a:r>
+            <a:endParaRPr lang="en-US" sz="900" dirty="0"/>
+          </a:p>
+        </p:txBody>
+      </p:sp>
+    </p:spTree>
+  </p:cSld>
+  <p:clrMapOvr>
+    <a:masterClrMapping/>
+  </p:clrMapOvr>
+</p:sld>
+</file>
+
+<file path=ppt/slides/slide8.xml><?xml version="1.0" encoding="utf-8"?>
+<p:sld xmlns:a="http://schemas.openxmlformats.org/drawingml/2006/main" xmlns:r="http://schemas.openxmlformats.org/officeDocument/2006/relationships" xmlns:p="http://schemas.openxmlformats.org/presentationml/2006/main">
+  <p:cSld name="Slide 8">
     <p:bg>
       <p:bgPr>
         <a:solidFill>

</xml_diff>